<commit_message>
UI and Backend Changes
</commit_message>
<xml_diff>
--- a/docs/dissertation_presentation.pptx
+++ b/docs/dissertation_presentation.pptx
@@ -5,18 +5,21 @@
     <p:sldMasterId id="2147483648" r:id="rId1"/>
   </p:sldMasterIdLst>
   <p:sldIdLst>
-    <p:sldId id="256" r:id="rId7"/>
-    <p:sldId id="257" r:id="rId8"/>
-    <p:sldId id="258" r:id="rId9"/>
-    <p:sldId id="259" r:id="rId10"/>
-    <p:sldId id="260" r:id="rId11"/>
-    <p:sldId id="261" r:id="rId12"/>
-    <p:sldId id="262" r:id="rId13"/>
-    <p:sldId id="263" r:id="rId14"/>
-    <p:sldId id="264" r:id="rId15"/>
-    <p:sldId id="265" r:id="rId16"/>
+    <p:sldId id="256" r:id="rId2"/>
+    <p:sldId id="257" r:id="rId3"/>
+    <p:sldId id="258" r:id="rId4"/>
+    <p:sldId id="259" r:id="rId5"/>
+    <p:sldId id="260" r:id="rId6"/>
+    <p:sldId id="261" r:id="rId7"/>
+    <p:sldId id="262" r:id="rId8"/>
+    <p:sldId id="263" r:id="rId9"/>
+    <p:sldId id="264" r:id="rId10"/>
+    <p:sldId id="267" r:id="rId11"/>
+    <p:sldId id="268" r:id="rId12"/>
+    <p:sldId id="265" r:id="rId13"/>
+    <p:sldId id="266" r:id="rId14"/>
   </p:sldIdLst>
-  <p:sldSz cx="12191695" cy="6858000" type="screen4x3"/>
+  <p:sldSz cx="12192000" cy="6858000"/>
   <p:notesSz cx="6858000" cy="9144000"/>
   <p:defaultTextStyle>
     <a:defPPr>
@@ -113,6 +116,22 @@
       </a:defRPr>
     </a:lvl9pPr>
   </p:defaultTextStyle>
+  <p:extLst>
+    <p:ext uri="{EFAFB233-063F-42B5-8137-9DF3F51BA10A}">
+      <p15:sldGuideLst xmlns:p15="http://schemas.microsoft.com/office/powerpoint/2012/main">
+        <p15:guide id="1" orient="horz" pos="2160">
+          <p15:clr>
+            <a:srgbClr val="A4A3A4"/>
+          </p15:clr>
+        </p15:guide>
+        <p15:guide id="2" pos="2880">
+          <p15:clr>
+            <a:srgbClr val="A4A3A4"/>
+          </p15:clr>
+        </p15:guide>
+      </p15:sldGuideLst>
+    </p:ext>
+  </p:extLst>
 </p:presentation>
 </file>
 
@@ -154,10 +173,9 @@
           <a:lstStyle/>
           <a:p>
             <a:r>
-              <a:rPr lang="en-US" smtClean="0"/>
+              <a:rPr lang="en-US"/>
               <a:t>Click to edit Master title style</a:t>
             </a:r>
-            <a:endParaRPr lang="en-US"/>
           </a:p>
         </p:txBody>
       </p:sp>
@@ -273,10 +291,9 @@
           </a:lstStyle>
           <a:p>
             <a:r>
-              <a:rPr lang="en-US" smtClean="0"/>
+              <a:rPr lang="en-US"/>
               <a:t>Click to edit Master subtitle style</a:t>
             </a:r>
-            <a:endParaRPr lang="en-US"/>
           </a:p>
         </p:txBody>
       </p:sp>
@@ -297,7 +314,7 @@
           <a:p>
             <a:fld id="{5BCAD085-E8A6-8845-BD4E-CB4CCA059FC4}" type="datetimeFigureOut">
               <a:rPr lang="en-US" smtClean="0"/>
-              <a:t>1/27/13</a:t>
+              <a:t>5/3/2026</a:t>
             </a:fld>
             <a:endParaRPr lang="en-US"/>
           </a:p>
@@ -391,10 +408,9 @@
           <a:lstStyle/>
           <a:p>
             <a:r>
-              <a:rPr lang="en-US" smtClean="0"/>
+              <a:rPr lang="en-US"/>
               <a:t>Click to edit Master title style</a:t>
             </a:r>
-            <a:endParaRPr lang="en-US"/>
           </a:p>
         </p:txBody>
       </p:sp>
@@ -415,38 +431,37 @@
           <a:p>
             <a:pPr lvl="0"/>
             <a:r>
-              <a:rPr lang="en-US" smtClean="0"/>
+              <a:rPr lang="en-US"/>
               <a:t>Click to edit Master text styles</a:t>
             </a:r>
           </a:p>
           <a:p>
             <a:pPr lvl="1"/>
             <a:r>
-              <a:rPr lang="en-US" smtClean="0"/>
+              <a:rPr lang="en-US"/>
               <a:t>Second level</a:t>
             </a:r>
           </a:p>
           <a:p>
             <a:pPr lvl="2"/>
             <a:r>
-              <a:rPr lang="en-US" smtClean="0"/>
+              <a:rPr lang="en-US"/>
               <a:t>Third level</a:t>
             </a:r>
           </a:p>
           <a:p>
             <a:pPr lvl="3"/>
             <a:r>
-              <a:rPr lang="en-US" smtClean="0"/>
+              <a:rPr lang="en-US"/>
               <a:t>Fourth level</a:t>
             </a:r>
           </a:p>
           <a:p>
             <a:pPr lvl="4"/>
             <a:r>
-              <a:rPr lang="en-US" smtClean="0"/>
+              <a:rPr lang="en-US"/>
               <a:t>Fifth level</a:t>
             </a:r>
-            <a:endParaRPr lang="en-US"/>
           </a:p>
         </p:txBody>
       </p:sp>
@@ -467,7 +482,7 @@
           <a:p>
             <a:fld id="{5BCAD085-E8A6-8845-BD4E-CB4CCA059FC4}" type="datetimeFigureOut">
               <a:rPr lang="en-US" smtClean="0"/>
-              <a:t>1/27/13</a:t>
+              <a:t>5/3/2026</a:t>
             </a:fld>
             <a:endParaRPr lang="en-US"/>
           </a:p>
@@ -566,10 +581,9 @@
           <a:lstStyle/>
           <a:p>
             <a:r>
-              <a:rPr lang="en-US" smtClean="0"/>
+              <a:rPr lang="en-US"/>
               <a:t>Click to edit Master title style</a:t>
             </a:r>
-            <a:endParaRPr lang="en-US"/>
           </a:p>
         </p:txBody>
       </p:sp>
@@ -595,38 +609,37 @@
           <a:p>
             <a:pPr lvl="0"/>
             <a:r>
-              <a:rPr lang="en-US" smtClean="0"/>
+              <a:rPr lang="en-US"/>
               <a:t>Click to edit Master text styles</a:t>
             </a:r>
           </a:p>
           <a:p>
             <a:pPr lvl="1"/>
             <a:r>
-              <a:rPr lang="en-US" smtClean="0"/>
+              <a:rPr lang="en-US"/>
               <a:t>Second level</a:t>
             </a:r>
           </a:p>
           <a:p>
             <a:pPr lvl="2"/>
             <a:r>
-              <a:rPr lang="en-US" smtClean="0"/>
+              <a:rPr lang="en-US"/>
               <a:t>Third level</a:t>
             </a:r>
           </a:p>
           <a:p>
             <a:pPr lvl="3"/>
             <a:r>
-              <a:rPr lang="en-US" smtClean="0"/>
+              <a:rPr lang="en-US"/>
               <a:t>Fourth level</a:t>
             </a:r>
           </a:p>
           <a:p>
             <a:pPr lvl="4"/>
             <a:r>
-              <a:rPr lang="en-US" smtClean="0"/>
+              <a:rPr lang="en-US"/>
               <a:t>Fifth level</a:t>
             </a:r>
-            <a:endParaRPr lang="en-US"/>
           </a:p>
         </p:txBody>
       </p:sp>
@@ -647,7 +660,7 @@
           <a:p>
             <a:fld id="{5BCAD085-E8A6-8845-BD4E-CB4CCA059FC4}" type="datetimeFigureOut">
               <a:rPr lang="en-US" smtClean="0"/>
-              <a:t>1/27/13</a:t>
+              <a:t>5/3/2026</a:t>
             </a:fld>
             <a:endParaRPr lang="en-US"/>
           </a:p>
@@ -741,10 +754,9 @@
           <a:lstStyle/>
           <a:p>
             <a:r>
-              <a:rPr lang="en-US" smtClean="0"/>
+              <a:rPr lang="en-US"/>
               <a:t>Click to edit Master title style</a:t>
             </a:r>
-            <a:endParaRPr lang="en-US"/>
           </a:p>
         </p:txBody>
       </p:sp>
@@ -765,38 +777,37 @@
           <a:p>
             <a:pPr lvl="0"/>
             <a:r>
-              <a:rPr lang="en-US" smtClean="0"/>
+              <a:rPr lang="en-US"/>
               <a:t>Click to edit Master text styles</a:t>
             </a:r>
           </a:p>
           <a:p>
             <a:pPr lvl="1"/>
             <a:r>
-              <a:rPr lang="en-US" smtClean="0"/>
+              <a:rPr lang="en-US"/>
               <a:t>Second level</a:t>
             </a:r>
           </a:p>
           <a:p>
             <a:pPr lvl="2"/>
             <a:r>
-              <a:rPr lang="en-US" smtClean="0"/>
+              <a:rPr lang="en-US"/>
               <a:t>Third level</a:t>
             </a:r>
           </a:p>
           <a:p>
             <a:pPr lvl="3"/>
             <a:r>
-              <a:rPr lang="en-US" smtClean="0"/>
+              <a:rPr lang="en-US"/>
               <a:t>Fourth level</a:t>
             </a:r>
           </a:p>
           <a:p>
             <a:pPr lvl="4"/>
             <a:r>
-              <a:rPr lang="en-US" smtClean="0"/>
+              <a:rPr lang="en-US"/>
               <a:t>Fifth level</a:t>
             </a:r>
-            <a:endParaRPr lang="en-US"/>
           </a:p>
         </p:txBody>
       </p:sp>
@@ -817,7 +828,7 @@
           <a:p>
             <a:fld id="{5BCAD085-E8A6-8845-BD4E-CB4CCA059FC4}" type="datetimeFigureOut">
               <a:rPr lang="en-US" smtClean="0"/>
-              <a:t>1/27/13</a:t>
+              <a:t>5/3/2026</a:t>
             </a:fld>
             <a:endParaRPr lang="en-US"/>
           </a:p>
@@ -920,10 +931,9 @@
           </a:lstStyle>
           <a:p>
             <a:r>
-              <a:rPr lang="en-US" smtClean="0"/>
+              <a:rPr lang="en-US"/>
               <a:t>Click to edit Master title style</a:t>
             </a:r>
-            <a:endParaRPr lang="en-US"/>
           </a:p>
         </p:txBody>
       </p:sp>
@@ -1040,7 +1050,7 @@
           <a:p>
             <a:pPr lvl="0"/>
             <a:r>
-              <a:rPr lang="en-US" smtClean="0"/>
+              <a:rPr lang="en-US"/>
               <a:t>Click to edit Master text styles</a:t>
             </a:r>
           </a:p>
@@ -1063,7 +1073,7 @@
           <a:p>
             <a:fld id="{5BCAD085-E8A6-8845-BD4E-CB4CCA059FC4}" type="datetimeFigureOut">
               <a:rPr lang="en-US" smtClean="0"/>
-              <a:t>1/27/13</a:t>
+              <a:t>5/3/2026</a:t>
             </a:fld>
             <a:endParaRPr lang="en-US"/>
           </a:p>
@@ -1157,10 +1167,9 @@
           <a:lstStyle/>
           <a:p>
             <a:r>
-              <a:rPr lang="en-US" smtClean="0"/>
+              <a:rPr lang="en-US"/>
               <a:t>Click to edit Master title style</a:t>
             </a:r>
-            <a:endParaRPr lang="en-US"/>
           </a:p>
         </p:txBody>
       </p:sp>
@@ -1214,38 +1223,37 @@
           <a:p>
             <a:pPr lvl="0"/>
             <a:r>
-              <a:rPr lang="en-US" smtClean="0"/>
+              <a:rPr lang="en-US"/>
               <a:t>Click to edit Master text styles</a:t>
             </a:r>
           </a:p>
           <a:p>
             <a:pPr lvl="1"/>
             <a:r>
-              <a:rPr lang="en-US" smtClean="0"/>
+              <a:rPr lang="en-US"/>
               <a:t>Second level</a:t>
             </a:r>
           </a:p>
           <a:p>
             <a:pPr lvl="2"/>
             <a:r>
-              <a:rPr lang="en-US" smtClean="0"/>
+              <a:rPr lang="en-US"/>
               <a:t>Third level</a:t>
             </a:r>
           </a:p>
           <a:p>
             <a:pPr lvl="3"/>
             <a:r>
-              <a:rPr lang="en-US" smtClean="0"/>
+              <a:rPr lang="en-US"/>
               <a:t>Fourth level</a:t>
             </a:r>
           </a:p>
           <a:p>
             <a:pPr lvl="4"/>
             <a:r>
-              <a:rPr lang="en-US" smtClean="0"/>
+              <a:rPr lang="en-US"/>
               <a:t>Fifth level</a:t>
             </a:r>
-            <a:endParaRPr lang="en-US"/>
           </a:p>
         </p:txBody>
       </p:sp>
@@ -1299,38 +1307,37 @@
           <a:p>
             <a:pPr lvl="0"/>
             <a:r>
-              <a:rPr lang="en-US" smtClean="0"/>
+              <a:rPr lang="en-US"/>
               <a:t>Click to edit Master text styles</a:t>
             </a:r>
           </a:p>
           <a:p>
             <a:pPr lvl="1"/>
             <a:r>
-              <a:rPr lang="en-US" smtClean="0"/>
+              <a:rPr lang="en-US"/>
               <a:t>Second level</a:t>
             </a:r>
           </a:p>
           <a:p>
             <a:pPr lvl="2"/>
             <a:r>
-              <a:rPr lang="en-US" smtClean="0"/>
+              <a:rPr lang="en-US"/>
               <a:t>Third level</a:t>
             </a:r>
           </a:p>
           <a:p>
             <a:pPr lvl="3"/>
             <a:r>
-              <a:rPr lang="en-US" smtClean="0"/>
+              <a:rPr lang="en-US"/>
               <a:t>Fourth level</a:t>
             </a:r>
           </a:p>
           <a:p>
             <a:pPr lvl="4"/>
             <a:r>
-              <a:rPr lang="en-US" smtClean="0"/>
+              <a:rPr lang="en-US"/>
               <a:t>Fifth level</a:t>
             </a:r>
-            <a:endParaRPr lang="en-US"/>
           </a:p>
         </p:txBody>
       </p:sp>
@@ -1351,7 +1358,7 @@
           <a:p>
             <a:fld id="{5BCAD085-E8A6-8845-BD4E-CB4CCA059FC4}" type="datetimeFigureOut">
               <a:rPr lang="en-US" smtClean="0"/>
-              <a:t>1/27/13</a:t>
+              <a:t>5/3/2026</a:t>
             </a:fld>
             <a:endParaRPr lang="en-US"/>
           </a:p>
@@ -1449,10 +1456,9 @@
           </a:lstStyle>
           <a:p>
             <a:r>
-              <a:rPr lang="en-US" smtClean="0"/>
+              <a:rPr lang="en-US"/>
               <a:t>Click to edit Master title style</a:t>
             </a:r>
-            <a:endParaRPr lang="en-US"/>
           </a:p>
         </p:txBody>
       </p:sp>
@@ -1515,7 +1521,7 @@
           <a:p>
             <a:pPr lvl="0"/>
             <a:r>
-              <a:rPr lang="en-US" smtClean="0"/>
+              <a:rPr lang="en-US"/>
               <a:t>Click to edit Master text styles</a:t>
             </a:r>
           </a:p>
@@ -1571,38 +1577,37 @@
           <a:p>
             <a:pPr lvl="0"/>
             <a:r>
-              <a:rPr lang="en-US" smtClean="0"/>
+              <a:rPr lang="en-US"/>
               <a:t>Click to edit Master text styles</a:t>
             </a:r>
           </a:p>
           <a:p>
             <a:pPr lvl="1"/>
             <a:r>
-              <a:rPr lang="en-US" smtClean="0"/>
+              <a:rPr lang="en-US"/>
               <a:t>Second level</a:t>
             </a:r>
           </a:p>
           <a:p>
             <a:pPr lvl="2"/>
             <a:r>
-              <a:rPr lang="en-US" smtClean="0"/>
+              <a:rPr lang="en-US"/>
               <a:t>Third level</a:t>
             </a:r>
           </a:p>
           <a:p>
             <a:pPr lvl="3"/>
             <a:r>
-              <a:rPr lang="en-US" smtClean="0"/>
+              <a:rPr lang="en-US"/>
               <a:t>Fourth level</a:t>
             </a:r>
           </a:p>
           <a:p>
             <a:pPr lvl="4"/>
             <a:r>
-              <a:rPr lang="en-US" smtClean="0"/>
+              <a:rPr lang="en-US"/>
               <a:t>Fifth level</a:t>
             </a:r>
-            <a:endParaRPr lang="en-US"/>
           </a:p>
         </p:txBody>
       </p:sp>
@@ -1665,7 +1670,7 @@
           <a:p>
             <a:pPr lvl="0"/>
             <a:r>
-              <a:rPr lang="en-US" smtClean="0"/>
+              <a:rPr lang="en-US"/>
               <a:t>Click to edit Master text styles</a:t>
             </a:r>
           </a:p>
@@ -1721,38 +1726,37 @@
           <a:p>
             <a:pPr lvl="0"/>
             <a:r>
-              <a:rPr lang="en-US" smtClean="0"/>
+              <a:rPr lang="en-US"/>
               <a:t>Click to edit Master text styles</a:t>
             </a:r>
           </a:p>
           <a:p>
             <a:pPr lvl="1"/>
             <a:r>
-              <a:rPr lang="en-US" smtClean="0"/>
+              <a:rPr lang="en-US"/>
               <a:t>Second level</a:t>
             </a:r>
           </a:p>
           <a:p>
             <a:pPr lvl="2"/>
             <a:r>
-              <a:rPr lang="en-US" smtClean="0"/>
+              <a:rPr lang="en-US"/>
               <a:t>Third level</a:t>
             </a:r>
           </a:p>
           <a:p>
             <a:pPr lvl="3"/>
             <a:r>
-              <a:rPr lang="en-US" smtClean="0"/>
+              <a:rPr lang="en-US"/>
               <a:t>Fourth level</a:t>
             </a:r>
           </a:p>
           <a:p>
             <a:pPr lvl="4"/>
             <a:r>
-              <a:rPr lang="en-US" smtClean="0"/>
+              <a:rPr lang="en-US"/>
               <a:t>Fifth level</a:t>
             </a:r>
-            <a:endParaRPr lang="en-US"/>
           </a:p>
         </p:txBody>
       </p:sp>
@@ -1773,7 +1777,7 @@
           <a:p>
             <a:fld id="{5BCAD085-E8A6-8845-BD4E-CB4CCA059FC4}" type="datetimeFigureOut">
               <a:rPr lang="en-US" smtClean="0"/>
-              <a:t>1/27/13</a:t>
+              <a:t>5/3/2026</a:t>
             </a:fld>
             <a:endParaRPr lang="en-US"/>
           </a:p>
@@ -1867,10 +1871,9 @@
           <a:lstStyle/>
           <a:p>
             <a:r>
-              <a:rPr lang="en-US" smtClean="0"/>
+              <a:rPr lang="en-US"/>
               <a:t>Click to edit Master title style</a:t>
             </a:r>
-            <a:endParaRPr lang="en-US"/>
           </a:p>
         </p:txBody>
       </p:sp>
@@ -1891,7 +1894,7 @@
           <a:p>
             <a:fld id="{5BCAD085-E8A6-8845-BD4E-CB4CCA059FC4}" type="datetimeFigureOut">
               <a:rPr lang="en-US" smtClean="0"/>
-              <a:t>1/27/13</a:t>
+              <a:t>5/3/2026</a:t>
             </a:fld>
             <a:endParaRPr lang="en-US"/>
           </a:p>
@@ -1986,7 +1989,7 @@
           <a:p>
             <a:fld id="{5BCAD085-E8A6-8845-BD4E-CB4CCA059FC4}" type="datetimeFigureOut">
               <a:rPr lang="en-US" smtClean="0"/>
-              <a:t>1/27/13</a:t>
+              <a:t>5/3/2026</a:t>
             </a:fld>
             <a:endParaRPr lang="en-US"/>
           </a:p>
@@ -2089,10 +2092,9 @@
           </a:lstStyle>
           <a:p>
             <a:r>
-              <a:rPr lang="en-US" smtClean="0"/>
+              <a:rPr lang="en-US"/>
               <a:t>Click to edit Master title style</a:t>
             </a:r>
-            <a:endParaRPr lang="en-US"/>
           </a:p>
         </p:txBody>
       </p:sp>
@@ -2146,38 +2148,37 @@
           <a:p>
             <a:pPr lvl="0"/>
             <a:r>
-              <a:rPr lang="en-US" smtClean="0"/>
+              <a:rPr lang="en-US"/>
               <a:t>Click to edit Master text styles</a:t>
             </a:r>
           </a:p>
           <a:p>
             <a:pPr lvl="1"/>
             <a:r>
-              <a:rPr lang="en-US" smtClean="0"/>
+              <a:rPr lang="en-US"/>
               <a:t>Second level</a:t>
             </a:r>
           </a:p>
           <a:p>
             <a:pPr lvl="2"/>
             <a:r>
-              <a:rPr lang="en-US" smtClean="0"/>
+              <a:rPr lang="en-US"/>
               <a:t>Third level</a:t>
             </a:r>
           </a:p>
           <a:p>
             <a:pPr lvl="3"/>
             <a:r>
-              <a:rPr lang="en-US" smtClean="0"/>
+              <a:rPr lang="en-US"/>
               <a:t>Fourth level</a:t>
             </a:r>
           </a:p>
           <a:p>
             <a:pPr lvl="4"/>
             <a:r>
-              <a:rPr lang="en-US" smtClean="0"/>
+              <a:rPr lang="en-US"/>
               <a:t>Fifth level</a:t>
             </a:r>
-            <a:endParaRPr lang="en-US"/>
           </a:p>
         </p:txBody>
       </p:sp>
@@ -2240,7 +2241,7 @@
           <a:p>
             <a:pPr lvl="0"/>
             <a:r>
-              <a:rPr lang="en-US" smtClean="0"/>
+              <a:rPr lang="en-US"/>
               <a:t>Click to edit Master text styles</a:t>
             </a:r>
           </a:p>
@@ -2263,7 +2264,7 @@
           <a:p>
             <a:fld id="{5BCAD085-E8A6-8845-BD4E-CB4CCA059FC4}" type="datetimeFigureOut">
               <a:rPr lang="en-US" smtClean="0"/>
-              <a:t>1/27/13</a:t>
+              <a:t>5/3/2026</a:t>
             </a:fld>
             <a:endParaRPr lang="en-US"/>
           </a:p>
@@ -2366,10 +2367,9 @@
           </a:lstStyle>
           <a:p>
             <a:r>
-              <a:rPr lang="en-US" smtClean="0"/>
+              <a:rPr lang="en-US"/>
               <a:t>Click to edit Master title style</a:t>
             </a:r>
-            <a:endParaRPr lang="en-US"/>
           </a:p>
         </p:txBody>
       </p:sp>
@@ -2493,7 +2493,7 @@
           <a:p>
             <a:pPr lvl="0"/>
             <a:r>
-              <a:rPr lang="en-US" smtClean="0"/>
+              <a:rPr lang="en-US"/>
               <a:t>Click to edit Master text styles</a:t>
             </a:r>
           </a:p>
@@ -2516,7 +2516,7 @@
           <a:p>
             <a:fld id="{5BCAD085-E8A6-8845-BD4E-CB4CCA059FC4}" type="datetimeFigureOut">
               <a:rPr lang="en-US" smtClean="0"/>
-              <a:t>1/27/13</a:t>
+              <a:t>5/3/2026</a:t>
             </a:fld>
             <a:endParaRPr lang="en-US"/>
           </a:p>
@@ -2625,10 +2625,9 @@
           <a:lstStyle/>
           <a:p>
             <a:r>
-              <a:rPr lang="en-US" smtClean="0"/>
+              <a:rPr lang="en-US"/>
               <a:t>Click to edit Master title style</a:t>
             </a:r>
-            <a:endParaRPr lang="en-US"/>
           </a:p>
         </p:txBody>
       </p:sp>
@@ -2659,38 +2658,37 @@
           <a:p>
             <a:pPr lvl="0"/>
             <a:r>
-              <a:rPr lang="en-US" smtClean="0"/>
+              <a:rPr lang="en-US"/>
               <a:t>Click to edit Master text styles</a:t>
             </a:r>
           </a:p>
           <a:p>
             <a:pPr lvl="1"/>
             <a:r>
-              <a:rPr lang="en-US" smtClean="0"/>
+              <a:rPr lang="en-US"/>
               <a:t>Second level</a:t>
             </a:r>
           </a:p>
           <a:p>
             <a:pPr lvl="2"/>
             <a:r>
-              <a:rPr lang="en-US" smtClean="0"/>
+              <a:rPr lang="en-US"/>
               <a:t>Third level</a:t>
             </a:r>
           </a:p>
           <a:p>
             <a:pPr lvl="3"/>
             <a:r>
-              <a:rPr lang="en-US" smtClean="0"/>
+              <a:rPr lang="en-US"/>
               <a:t>Fourth level</a:t>
             </a:r>
           </a:p>
           <a:p>
             <a:pPr lvl="4"/>
             <a:r>
-              <a:rPr lang="en-US" smtClean="0"/>
+              <a:rPr lang="en-US"/>
               <a:t>Fifth level</a:t>
             </a:r>
-            <a:endParaRPr lang="en-US"/>
           </a:p>
         </p:txBody>
       </p:sp>
@@ -2729,7 +2727,7 @@
           <a:p>
             <a:fld id="{5BCAD085-E8A6-8845-BD4E-CB4CCA059FC4}" type="datetimeFigureOut">
               <a:rPr lang="en-US" smtClean="0"/>
-              <a:t>1/27/13</a:t>
+              <a:t>5/3/2026</a:t>
             </a:fld>
             <a:endParaRPr lang="en-US"/>
           </a:p>
@@ -3088,7 +3086,7 @@
 </file>
 
 <file path=ppt/slides/slide1.xml><?xml version="1.0" encoding="utf-8"?>
-<p:sld xmlns:a="http://schemas.openxmlformats.org/drawingml/2006/main" xmlns:p="http://schemas.openxmlformats.org/presentationml/2006/main" xmlns:r="http://schemas.openxmlformats.org/officeDocument/2006/relationships">
+<p:sld xmlns:a="http://schemas.openxmlformats.org/drawingml/2006/main" xmlns:r="http://schemas.openxmlformats.org/officeDocument/2006/relationships" xmlns:p="http://schemas.openxmlformats.org/presentationml/2006/main">
   <p:cSld>
     <p:bg>
       <p:bgPr>
@@ -3104,7 +3102,14 @@
         <p:cNvGrpSpPr/>
         <p:nvPr/>
       </p:nvGrpSpPr>
-      <p:grpSpPr/>
+      <p:grpSpPr>
+        <a:xfrm>
+          <a:off x="0" y="0"/>
+          <a:ext cx="0" cy="0"/>
+          <a:chOff x="0" y="0"/>
+          <a:chExt cx="0" cy="0"/>
+        </a:xfrm>
+      </p:grpSpPr>
       <p:sp>
         <p:nvSpPr>
           <p:cNvPr id="2" name="Rectangle 1"/>
@@ -3147,6 +3152,7 @@
           <a:lstStyle/>
           <a:p>
             <a:pPr algn="ctr"/>
+            <a:endParaRPr/>
           </a:p>
         </p:txBody>
       </p:sp>
@@ -3327,7 +3333,278 @@
 </file>
 
 <file path=ppt/slides/slide10.xml><?xml version="1.0" encoding="utf-8"?>
-<p:sld xmlns:a="http://schemas.openxmlformats.org/drawingml/2006/main" xmlns:p="http://schemas.openxmlformats.org/presentationml/2006/main" xmlns:r="http://schemas.openxmlformats.org/officeDocument/2006/relationships">
+<p:sld xmlns:a="http://schemas.openxmlformats.org/drawingml/2006/main" xmlns:r="http://schemas.openxmlformats.org/officeDocument/2006/relationships" xmlns:p="http://schemas.openxmlformats.org/presentationml/2006/main">
+  <p:cSld>
+    <p:bg>
+      <p:bgPr>
+        <a:solidFill>
+          <a:srgbClr val="F7FAF9"/>
+        </a:solidFill>
+        <a:effectLst/>
+      </p:bgPr>
+    </p:bg>
+    <p:spTree>
+      <p:nvGrpSpPr>
+        <p:cNvPr id="1" name=""/>
+        <p:cNvGrpSpPr/>
+        <p:nvPr/>
+      </p:nvGrpSpPr>
+      <p:grpSpPr>
+        <a:xfrm>
+          <a:off x="0" y="0"/>
+          <a:ext cx="0" cy="0"/>
+          <a:chOff x="0" y="0"/>
+          <a:chExt cx="0" cy="0"/>
+        </a:xfrm>
+      </p:grpSpPr>
+      <p:sp>
+        <p:nvSpPr>
+          <p:cNvPr id="2" name="TextBox 1"/>
+          <p:cNvSpPr txBox="1"/>
+          <p:nvPr/>
+        </p:nvSpPr>
+        <p:spPr>
+          <a:xfrm>
+            <a:off x="640080" y="411480"/>
+            <a:ext cx="4136069" cy="492443"/>
+          </a:xfrm>
+          <a:prstGeom prst="rect">
+            <a:avLst/>
+          </a:prstGeom>
+          <a:noFill/>
+        </p:spPr>
+        <p:txBody>
+          <a:bodyPr wrap="none">
+            <a:spAutoFit/>
+          </a:bodyPr>
+          <a:lstStyle/>
+          <a:p>
+            <a:pPr>
+              <a:defRPr sz="2600" b="1">
+                <a:solidFill>
+                  <a:srgbClr val="0D544E"/>
+                </a:solidFill>
+                <a:latin typeface="Arial"/>
+              </a:defRPr>
+            </a:pPr>
+            <a:r>
+              <a:rPr lang="en-US" dirty="0"/>
+              <a:t>TF-IDF Retrieval Process</a:t>
+            </a:r>
+            <a:endParaRPr dirty="0"/>
+          </a:p>
+        </p:txBody>
+      </p:sp>
+      <p:pic>
+        <p:nvPicPr>
+          <p:cNvPr id="5" name="Picture 4">
+            <a:extLst>
+              <a:ext uri="{FF2B5EF4-FFF2-40B4-BE49-F238E27FC236}">
+                <a16:creationId xmlns:a16="http://schemas.microsoft.com/office/drawing/2014/main" id="{A0A1C852-A699-4A3F-86B2-0531697FA3DC}"/>
+              </a:ext>
+            </a:extLst>
+          </p:cNvPr>
+          <p:cNvPicPr>
+            <a:picLocks noChangeAspect="1"/>
+          </p:cNvPicPr>
+          <p:nvPr/>
+        </p:nvPicPr>
+        <p:blipFill>
+          <a:blip r:embed="rId2"/>
+          <a:stretch>
+            <a:fillRect/>
+          </a:stretch>
+        </p:blipFill>
+        <p:spPr>
+          <a:xfrm>
+            <a:off x="1271059" y="1885950"/>
+            <a:ext cx="3333750" cy="3086100"/>
+          </a:xfrm>
+          <a:prstGeom prst="rect">
+            <a:avLst/>
+          </a:prstGeom>
+        </p:spPr>
+      </p:pic>
+      <p:pic>
+        <p:nvPicPr>
+          <p:cNvPr id="7" name="Picture 6">
+            <a:extLst>
+              <a:ext uri="{FF2B5EF4-FFF2-40B4-BE49-F238E27FC236}">
+                <a16:creationId xmlns:a16="http://schemas.microsoft.com/office/drawing/2014/main" id="{2FF3E46D-E796-4EA7-8821-60B24A08DEC8}"/>
+              </a:ext>
+            </a:extLst>
+          </p:cNvPr>
+          <p:cNvPicPr>
+            <a:picLocks noChangeAspect="1"/>
+          </p:cNvPicPr>
+          <p:nvPr/>
+        </p:nvPicPr>
+        <p:blipFill>
+          <a:blip r:embed="rId3"/>
+          <a:stretch>
+            <a:fillRect/>
+          </a:stretch>
+        </p:blipFill>
+        <p:spPr>
+          <a:xfrm>
+            <a:off x="5182658" y="2428875"/>
+            <a:ext cx="5924550" cy="2000250"/>
+          </a:xfrm>
+          <a:prstGeom prst="rect">
+            <a:avLst/>
+          </a:prstGeom>
+        </p:spPr>
+      </p:pic>
+    </p:spTree>
+    <p:extLst>
+      <p:ext uri="{BB962C8B-B14F-4D97-AF65-F5344CB8AC3E}">
+        <p14:creationId xmlns:p14="http://schemas.microsoft.com/office/powerpoint/2010/main" val="154801920"/>
+      </p:ext>
+    </p:extLst>
+  </p:cSld>
+  <p:clrMapOvr>
+    <a:masterClrMapping/>
+  </p:clrMapOvr>
+</p:sld>
+</file>
+
+<file path=ppt/slides/slide11.xml><?xml version="1.0" encoding="utf-8"?>
+<p:sld xmlns:a="http://schemas.openxmlformats.org/drawingml/2006/main" xmlns:r="http://schemas.openxmlformats.org/officeDocument/2006/relationships" xmlns:p="http://schemas.openxmlformats.org/presentationml/2006/main">
+  <p:cSld>
+    <p:bg>
+      <p:bgPr>
+        <a:solidFill>
+          <a:srgbClr val="F7FAF9"/>
+        </a:solidFill>
+        <a:effectLst/>
+      </p:bgPr>
+    </p:bg>
+    <p:spTree>
+      <p:nvGrpSpPr>
+        <p:cNvPr id="1" name=""/>
+        <p:cNvGrpSpPr/>
+        <p:nvPr/>
+      </p:nvGrpSpPr>
+      <p:grpSpPr>
+        <a:xfrm>
+          <a:off x="0" y="0"/>
+          <a:ext cx="0" cy="0"/>
+          <a:chOff x="0" y="0"/>
+          <a:chExt cx="0" cy="0"/>
+        </a:xfrm>
+      </p:grpSpPr>
+      <p:sp>
+        <p:nvSpPr>
+          <p:cNvPr id="2" name="TextBox 1"/>
+          <p:cNvSpPr txBox="1"/>
+          <p:nvPr/>
+        </p:nvSpPr>
+        <p:spPr>
+          <a:xfrm>
+            <a:off x="640080" y="411480"/>
+            <a:ext cx="4136069" cy="492443"/>
+          </a:xfrm>
+          <a:prstGeom prst="rect">
+            <a:avLst/>
+          </a:prstGeom>
+          <a:noFill/>
+        </p:spPr>
+        <p:txBody>
+          <a:bodyPr wrap="none">
+            <a:spAutoFit/>
+          </a:bodyPr>
+          <a:lstStyle/>
+          <a:p>
+            <a:pPr>
+              <a:defRPr sz="2600" b="1">
+                <a:solidFill>
+                  <a:srgbClr val="0D544E"/>
+                </a:solidFill>
+                <a:latin typeface="Arial"/>
+              </a:defRPr>
+            </a:pPr>
+            <a:r>
+              <a:rPr lang="en-US" dirty="0"/>
+              <a:t>TF-IDF Retrieval Process</a:t>
+            </a:r>
+            <a:endParaRPr dirty="0"/>
+          </a:p>
+        </p:txBody>
+      </p:sp>
+      <p:pic>
+        <p:nvPicPr>
+          <p:cNvPr id="4" name="Picture 3">
+            <a:extLst>
+              <a:ext uri="{FF2B5EF4-FFF2-40B4-BE49-F238E27FC236}">
+                <a16:creationId xmlns:a16="http://schemas.microsoft.com/office/drawing/2014/main" id="{6F51BF4A-D72A-4AD9-9198-3D2A8FA0B910}"/>
+              </a:ext>
+            </a:extLst>
+          </p:cNvPr>
+          <p:cNvPicPr>
+            <a:picLocks noChangeAspect="1"/>
+          </p:cNvPicPr>
+          <p:nvPr/>
+        </p:nvPicPr>
+        <p:blipFill>
+          <a:blip r:embed="rId2"/>
+          <a:stretch>
+            <a:fillRect/>
+          </a:stretch>
+        </p:blipFill>
+        <p:spPr>
+          <a:xfrm>
+            <a:off x="719667" y="2795587"/>
+            <a:ext cx="4267200" cy="1266825"/>
+          </a:xfrm>
+          <a:prstGeom prst="rect">
+            <a:avLst/>
+          </a:prstGeom>
+        </p:spPr>
+      </p:pic>
+      <p:pic>
+        <p:nvPicPr>
+          <p:cNvPr id="8" name="Picture 7">
+            <a:extLst>
+              <a:ext uri="{FF2B5EF4-FFF2-40B4-BE49-F238E27FC236}">
+                <a16:creationId xmlns:a16="http://schemas.microsoft.com/office/drawing/2014/main" id="{A4AAD52E-43FB-4C76-988F-A20664E35F0E}"/>
+              </a:ext>
+            </a:extLst>
+          </p:cNvPr>
+          <p:cNvPicPr>
+            <a:picLocks noChangeAspect="1"/>
+          </p:cNvPicPr>
+          <p:nvPr/>
+        </p:nvPicPr>
+        <p:blipFill rotWithShape="1">
+          <a:blip r:embed="rId3"/>
+          <a:srcRect/>
+          <a:stretch/>
+        </p:blipFill>
+        <p:spPr>
+          <a:xfrm>
+            <a:off x="5436658" y="1785936"/>
+            <a:ext cx="5314950" cy="3286125"/>
+          </a:xfrm>
+          <a:prstGeom prst="rect">
+            <a:avLst/>
+          </a:prstGeom>
+        </p:spPr>
+      </p:pic>
+    </p:spTree>
+    <p:extLst>
+      <p:ext uri="{BB962C8B-B14F-4D97-AF65-F5344CB8AC3E}">
+        <p14:creationId xmlns:p14="http://schemas.microsoft.com/office/powerpoint/2010/main" val="3228805745"/>
+      </p:ext>
+    </p:extLst>
+  </p:cSld>
+  <p:clrMapOvr>
+    <a:masterClrMapping/>
+  </p:clrMapOvr>
+</p:sld>
+</file>
+
+<file path=ppt/slides/slide12.xml><?xml version="1.0" encoding="utf-8"?>
+<p:sld xmlns:a="http://schemas.openxmlformats.org/drawingml/2006/main" xmlns:r="http://schemas.openxmlformats.org/officeDocument/2006/relationships" xmlns:p="http://schemas.openxmlformats.org/presentationml/2006/main">
   <p:cSld>
     <p:bg>
       <p:bgPr>
@@ -3343,7 +3620,205 @@
         <p:cNvGrpSpPr/>
         <p:nvPr/>
       </p:nvGrpSpPr>
-      <p:grpSpPr/>
+      <p:grpSpPr>
+        <a:xfrm>
+          <a:off x="0" y="0"/>
+          <a:ext cx="0" cy="0"/>
+          <a:chOff x="0" y="0"/>
+          <a:chExt cx="0" cy="0"/>
+        </a:xfrm>
+      </p:grpSpPr>
+      <p:sp>
+        <p:nvSpPr>
+          <p:cNvPr id="2" name="TextBox 1"/>
+          <p:cNvSpPr txBox="1"/>
+          <p:nvPr/>
+        </p:nvSpPr>
+        <p:spPr>
+          <a:xfrm>
+            <a:off x="640080" y="411480"/>
+            <a:ext cx="10581999" cy="492443"/>
+          </a:xfrm>
+          <a:prstGeom prst="rect">
+            <a:avLst/>
+          </a:prstGeom>
+          <a:noFill/>
+        </p:spPr>
+        <p:txBody>
+          <a:bodyPr wrap="none">
+            <a:spAutoFit/>
+          </a:bodyPr>
+          <a:lstStyle/>
+          <a:p>
+            <a:pPr>
+              <a:defRPr sz="2600" b="1">
+                <a:solidFill>
+                  <a:srgbClr val="FFFFFF"/>
+                </a:solidFill>
+                <a:latin typeface="Arial"/>
+              </a:defRPr>
+            </a:pPr>
+            <a:r>
+              <a:rPr lang="en-US" dirty="0"/>
+              <a:t>Why and Without Retrieval Based Response Generation (</a:t>
+            </a:r>
+            <a:r>
+              <a:rPr lang="en-US" i="1" dirty="0"/>
+              <a:t>TF-IDF</a:t>
+            </a:r>
+            <a:r>
+              <a:rPr lang="en-US" dirty="0"/>
+              <a:t>) </a:t>
+            </a:r>
+            <a:endParaRPr dirty="0"/>
+          </a:p>
+        </p:txBody>
+      </p:sp>
+      <p:sp>
+        <p:nvSpPr>
+          <p:cNvPr id="3" name="TextBox 2"/>
+          <p:cNvSpPr txBox="1"/>
+          <p:nvPr/>
+        </p:nvSpPr>
+        <p:spPr>
+          <a:xfrm>
+            <a:off x="822960" y="1417320"/>
+            <a:ext cx="5577840" cy="4480560"/>
+          </a:xfrm>
+          <a:prstGeom prst="rect">
+            <a:avLst/>
+          </a:prstGeom>
+          <a:noFill/>
+        </p:spPr>
+        <p:txBody>
+          <a:bodyPr wrap="square">
+            <a:spAutoFit/>
+          </a:bodyPr>
+          <a:lstStyle/>
+          <a:p>
+            <a:pPr>
+              <a:spcAft>
+                <a:spcPts val="0"/>
+              </a:spcAft>
+              <a:defRPr sz="2000">
+                <a:solidFill>
+                  <a:srgbClr val="ECF5F3"/>
+                </a:solidFill>
+                <a:latin typeface="Arial"/>
+              </a:defRPr>
+            </a:pPr>
+            <a:r>
+              <a:rPr dirty="0"/>
+              <a:t>The project delivered a substantial artefact that combined sequential NLP, retrieval-based response generation, and practical </a:t>
+            </a:r>
+            <a:r>
+              <a:rPr dirty="0" err="1"/>
+              <a:t>MLOps</a:t>
+            </a:r>
+            <a:r>
+              <a:rPr dirty="0"/>
+              <a:t> controls.</a:t>
+            </a:r>
+          </a:p>
+          <a:p>
+            <a:pPr>
+              <a:spcAft>
+                <a:spcPts val="0"/>
+              </a:spcAft>
+              <a:defRPr sz="2000">
+                <a:solidFill>
+                  <a:srgbClr val="ECF5F3"/>
+                </a:solidFill>
+                <a:latin typeface="Arial"/>
+              </a:defRPr>
+            </a:pPr>
+            <a:r>
+              <a:rPr dirty="0"/>
+              <a:t>Further work should extend real-user data collection, multilingual support, richer report-term coverage, and formal usability evaluation.</a:t>
+            </a:r>
+          </a:p>
+          <a:p>
+            <a:pPr>
+              <a:spcAft>
+                <a:spcPts val="0"/>
+              </a:spcAft>
+              <a:defRPr sz="2000">
+                <a:solidFill>
+                  <a:srgbClr val="ECF5F3"/>
+                </a:solidFill>
+                <a:latin typeface="Arial"/>
+              </a:defRPr>
+            </a:pPr>
+            <a:r>
+              <a:rPr dirty="0"/>
+              <a:t>The implemented platform is suitable as a bounded laboratory assistant and as a demonstrable final-year machine learning system.</a:t>
+            </a:r>
+          </a:p>
+        </p:txBody>
+      </p:sp>
+      <p:pic>
+        <p:nvPicPr>
+          <p:cNvPr id="6" name="Picture 5">
+            <a:extLst>
+              <a:ext uri="{FF2B5EF4-FFF2-40B4-BE49-F238E27FC236}">
+                <a16:creationId xmlns:a16="http://schemas.microsoft.com/office/drawing/2014/main" id="{B0FB2EE8-3B64-4423-A5C7-38EF845C4E7D}"/>
+              </a:ext>
+            </a:extLst>
+          </p:cNvPr>
+          <p:cNvPicPr>
+            <a:picLocks noChangeAspect="1"/>
+          </p:cNvPicPr>
+          <p:nvPr/>
+        </p:nvPicPr>
+        <p:blipFill>
+          <a:blip r:embed="rId2"/>
+          <a:stretch>
+            <a:fillRect/>
+          </a:stretch>
+        </p:blipFill>
+        <p:spPr>
+          <a:xfrm>
+            <a:off x="6494462" y="2288646"/>
+            <a:ext cx="4943475" cy="1704975"/>
+          </a:xfrm>
+          <a:prstGeom prst="rect">
+            <a:avLst/>
+          </a:prstGeom>
+        </p:spPr>
+      </p:pic>
+    </p:spTree>
+  </p:cSld>
+  <p:clrMapOvr>
+    <a:masterClrMapping/>
+  </p:clrMapOvr>
+</p:sld>
+</file>
+
+<file path=ppt/slides/slide13.xml><?xml version="1.0" encoding="utf-8"?>
+<p:sld xmlns:a="http://schemas.openxmlformats.org/drawingml/2006/main" xmlns:r="http://schemas.openxmlformats.org/officeDocument/2006/relationships" xmlns:p="http://schemas.openxmlformats.org/presentationml/2006/main">
+  <p:cSld>
+    <p:bg>
+      <p:bgPr>
+        <a:solidFill>
+          <a:srgbClr val="0E312F"/>
+        </a:solidFill>
+        <a:effectLst/>
+      </p:bgPr>
+    </p:bg>
+    <p:spTree>
+      <p:nvGrpSpPr>
+        <p:cNvPr id="1" name=""/>
+        <p:cNvGrpSpPr/>
+        <p:nvPr/>
+      </p:nvGrpSpPr>
+      <p:grpSpPr>
+        <a:xfrm>
+          <a:off x="0" y="0"/>
+          <a:ext cx="0" cy="0"/>
+          <a:chOff x="0" y="0"/>
+          <a:chExt cx="0" cy="0"/>
+        </a:xfrm>
+      </p:grpSpPr>
       <p:sp>
         <p:nvSpPr>
           <p:cNvPr id="2" name="TextBox 1"/>
@@ -3476,6 +3951,11 @@
         </p:spPr>
       </p:pic>
     </p:spTree>
+    <p:extLst>
+      <p:ext uri="{BB962C8B-B14F-4D97-AF65-F5344CB8AC3E}">
+        <p14:creationId xmlns:p14="http://schemas.microsoft.com/office/powerpoint/2010/main" val="2228521335"/>
+      </p:ext>
+    </p:extLst>
   </p:cSld>
   <p:clrMapOvr>
     <a:masterClrMapping/>
@@ -3484,7 +3964,7 @@
 </file>
 
 <file path=ppt/slides/slide2.xml><?xml version="1.0" encoding="utf-8"?>
-<p:sld xmlns:a="http://schemas.openxmlformats.org/drawingml/2006/main" xmlns:p="http://schemas.openxmlformats.org/presentationml/2006/main" xmlns:r="http://schemas.openxmlformats.org/officeDocument/2006/relationships">
+<p:sld xmlns:a="http://schemas.openxmlformats.org/drawingml/2006/main" xmlns:r="http://schemas.openxmlformats.org/officeDocument/2006/relationships" xmlns:p="http://schemas.openxmlformats.org/presentationml/2006/main">
   <p:cSld>
     <p:bg>
       <p:bgPr>
@@ -3500,7 +3980,14 @@
         <p:cNvGrpSpPr/>
         <p:nvPr/>
       </p:nvGrpSpPr>
-      <p:grpSpPr/>
+      <p:grpSpPr>
+        <a:xfrm>
+          <a:off x="0" y="0"/>
+          <a:ext cx="0" cy="0"/>
+          <a:chOff x="0" y="0"/>
+          <a:chExt cx="0" cy="0"/>
+        </a:xfrm>
+      </p:grpSpPr>
       <p:sp>
         <p:nvSpPr>
           <p:cNvPr id="2" name="TextBox 1"/>
@@ -3641,7 +4128,7 @@
 </file>
 
 <file path=ppt/slides/slide3.xml><?xml version="1.0" encoding="utf-8"?>
-<p:sld xmlns:a="http://schemas.openxmlformats.org/drawingml/2006/main" xmlns:p="http://schemas.openxmlformats.org/presentationml/2006/main" xmlns:r="http://schemas.openxmlformats.org/officeDocument/2006/relationships">
+<p:sld xmlns:a="http://schemas.openxmlformats.org/drawingml/2006/main" xmlns:r="http://schemas.openxmlformats.org/officeDocument/2006/relationships" xmlns:p="http://schemas.openxmlformats.org/presentationml/2006/main">
   <p:cSld>
     <p:bg>
       <p:bgPr>
@@ -3657,7 +4144,14 @@
         <p:cNvGrpSpPr/>
         <p:nvPr/>
       </p:nvGrpSpPr>
-      <p:grpSpPr/>
+      <p:grpSpPr>
+        <a:xfrm>
+          <a:off x="0" y="0"/>
+          <a:ext cx="0" cy="0"/>
+          <a:chOff x="0" y="0"/>
+          <a:chExt cx="0" cy="0"/>
+        </a:xfrm>
+      </p:grpSpPr>
       <p:sp>
         <p:nvSpPr>
           <p:cNvPr id="2" name="TextBox 1"/>
@@ -3798,7 +4292,7 @@
 </file>
 
 <file path=ppt/slides/slide4.xml><?xml version="1.0" encoding="utf-8"?>
-<p:sld xmlns:a="http://schemas.openxmlformats.org/drawingml/2006/main" xmlns:p="http://schemas.openxmlformats.org/presentationml/2006/main" xmlns:r="http://schemas.openxmlformats.org/officeDocument/2006/relationships">
+<p:sld xmlns:a="http://schemas.openxmlformats.org/drawingml/2006/main" xmlns:r="http://schemas.openxmlformats.org/officeDocument/2006/relationships" xmlns:p="http://schemas.openxmlformats.org/presentationml/2006/main">
   <p:cSld>
     <p:bg>
       <p:bgPr>
@@ -3814,7 +4308,14 @@
         <p:cNvGrpSpPr/>
         <p:nvPr/>
       </p:nvGrpSpPr>
-      <p:grpSpPr/>
+      <p:grpSpPr>
+        <a:xfrm>
+          <a:off x="0" y="0"/>
+          <a:ext cx="0" cy="0"/>
+          <a:chOff x="0" y="0"/>
+          <a:chExt cx="0" cy="0"/>
+        </a:xfrm>
+      </p:grpSpPr>
       <p:sp>
         <p:nvSpPr>
           <p:cNvPr id="2" name="TextBox 1"/>
@@ -3971,7 +4472,7 @@
 </file>
 
 <file path=ppt/slides/slide5.xml><?xml version="1.0" encoding="utf-8"?>
-<p:sld xmlns:a="http://schemas.openxmlformats.org/drawingml/2006/main" xmlns:p="http://schemas.openxmlformats.org/presentationml/2006/main" xmlns:r="http://schemas.openxmlformats.org/officeDocument/2006/relationships">
+<p:sld xmlns:a="http://schemas.openxmlformats.org/drawingml/2006/main" xmlns:r="http://schemas.openxmlformats.org/officeDocument/2006/relationships" xmlns:p="http://schemas.openxmlformats.org/presentationml/2006/main">
   <p:cSld>
     <p:bg>
       <p:bgPr>
@@ -3987,7 +4488,14 @@
         <p:cNvGrpSpPr/>
         <p:nvPr/>
       </p:nvGrpSpPr>
-      <p:grpSpPr/>
+      <p:grpSpPr>
+        <a:xfrm>
+          <a:off x="0" y="0"/>
+          <a:ext cx="0" cy="0"/>
+          <a:chOff x="0" y="0"/>
+          <a:chExt cx="0" cy="0"/>
+        </a:xfrm>
+      </p:grpSpPr>
       <p:sp>
         <p:nvSpPr>
           <p:cNvPr id="2" name="TextBox 1"/>
@@ -4128,7 +4636,7 @@
 </file>
 
 <file path=ppt/slides/slide6.xml><?xml version="1.0" encoding="utf-8"?>
-<p:sld xmlns:a="http://schemas.openxmlformats.org/drawingml/2006/main" xmlns:p="http://schemas.openxmlformats.org/presentationml/2006/main" xmlns:r="http://schemas.openxmlformats.org/officeDocument/2006/relationships">
+<p:sld xmlns:a="http://schemas.openxmlformats.org/drawingml/2006/main" xmlns:r="http://schemas.openxmlformats.org/officeDocument/2006/relationships" xmlns:p="http://schemas.openxmlformats.org/presentationml/2006/main">
   <p:cSld>
     <p:bg>
       <p:bgPr>
@@ -4144,7 +4652,14 @@
         <p:cNvGrpSpPr/>
         <p:nvPr/>
       </p:nvGrpSpPr>
-      <p:grpSpPr/>
+      <p:grpSpPr>
+        <a:xfrm>
+          <a:off x="0" y="0"/>
+          <a:ext cx="0" cy="0"/>
+          <a:chOff x="0" y="0"/>
+          <a:chExt cx="0" cy="0"/>
+        </a:xfrm>
+      </p:grpSpPr>
       <p:sp>
         <p:nvSpPr>
           <p:cNvPr id="2" name="TextBox 1"/>
@@ -4285,7 +4800,7 @@
 </file>
 
 <file path=ppt/slides/slide7.xml><?xml version="1.0" encoding="utf-8"?>
-<p:sld xmlns:a="http://schemas.openxmlformats.org/drawingml/2006/main" xmlns:p="http://schemas.openxmlformats.org/presentationml/2006/main" xmlns:r="http://schemas.openxmlformats.org/officeDocument/2006/relationships">
+<p:sld xmlns:a="http://schemas.openxmlformats.org/drawingml/2006/main" xmlns:r="http://schemas.openxmlformats.org/officeDocument/2006/relationships" xmlns:p="http://schemas.openxmlformats.org/presentationml/2006/main">
   <p:cSld>
     <p:bg>
       <p:bgPr>
@@ -4301,7 +4816,14 @@
         <p:cNvGrpSpPr/>
         <p:nvPr/>
       </p:nvGrpSpPr>
-      <p:grpSpPr/>
+      <p:grpSpPr>
+        <a:xfrm>
+          <a:off x="0" y="0"/>
+          <a:ext cx="0" cy="0"/>
+          <a:chOff x="0" y="0"/>
+          <a:chExt cx="0" cy="0"/>
+        </a:xfrm>
+      </p:grpSpPr>
       <p:sp>
         <p:nvSpPr>
           <p:cNvPr id="2" name="TextBox 1"/>
@@ -4442,7 +4964,7 @@
 </file>
 
 <file path=ppt/slides/slide8.xml><?xml version="1.0" encoding="utf-8"?>
-<p:sld xmlns:a="http://schemas.openxmlformats.org/drawingml/2006/main" xmlns:p="http://schemas.openxmlformats.org/presentationml/2006/main" xmlns:r="http://schemas.openxmlformats.org/officeDocument/2006/relationships">
+<p:sld xmlns:a="http://schemas.openxmlformats.org/drawingml/2006/main" xmlns:r="http://schemas.openxmlformats.org/officeDocument/2006/relationships" xmlns:p="http://schemas.openxmlformats.org/presentationml/2006/main">
   <p:cSld>
     <p:bg>
       <p:bgPr>
@@ -4458,7 +4980,14 @@
         <p:cNvGrpSpPr/>
         <p:nvPr/>
       </p:nvGrpSpPr>
-      <p:grpSpPr/>
+      <p:grpSpPr>
+        <a:xfrm>
+          <a:off x="0" y="0"/>
+          <a:ext cx="0" cy="0"/>
+          <a:chOff x="0" y="0"/>
+          <a:chExt cx="0" cy="0"/>
+        </a:xfrm>
+      </p:grpSpPr>
       <p:sp>
         <p:nvSpPr>
           <p:cNvPr id="2" name="TextBox 1"/>
@@ -4599,7 +5128,7 @@
 </file>
 
 <file path=ppt/slides/slide9.xml><?xml version="1.0" encoding="utf-8"?>
-<p:sld xmlns:a="http://schemas.openxmlformats.org/drawingml/2006/main" xmlns:p="http://schemas.openxmlformats.org/presentationml/2006/main" xmlns:r="http://schemas.openxmlformats.org/officeDocument/2006/relationships">
+<p:sld xmlns:a="http://schemas.openxmlformats.org/drawingml/2006/main" xmlns:r="http://schemas.openxmlformats.org/officeDocument/2006/relationships" xmlns:p="http://schemas.openxmlformats.org/presentationml/2006/main">
   <p:cSld>
     <p:bg>
       <p:bgPr>
@@ -4615,7 +5144,14 @@
         <p:cNvGrpSpPr/>
         <p:nvPr/>
       </p:nvGrpSpPr>
-      <p:grpSpPr/>
+      <p:grpSpPr>
+        <a:xfrm>
+          <a:off x="0" y="0"/>
+          <a:ext cx="0" cy="0"/>
+          <a:chOff x="0" y="0"/>
+          <a:chExt cx="0" cy="0"/>
+        </a:xfrm>
+      </p:grpSpPr>
       <p:sp>
         <p:nvSpPr>
           <p:cNvPr id="2" name="TextBox 1"/>

</xml_diff>